<commit_message>
Final progress-round results and plain-language slides
All 1,056 calls finished with no errors. Slides and READMEs now use the final
numbers and plain wording.
</commit_message>
<xml_diff>
--- a/presentation/CSE598_progress_presentation.pptx
+++ b/presentation/CSE598_progress_presentation.pptx
@@ -117,36 +117,36 @@
   <p:extLst>
     <p:ext uri="{521415D9-36F7-43E2-AB2F-B90AF26B5E84}">
       <p14:sectionLst xmlns:p14="http://schemas.microsoft.com/office/powerpoint/2010/main">
-        <p14:section name="Opening" id="{101e1577-2b91-e8d6-9363-c5379a98ad78}">
+        <p14:section name="Opening" id="{3caea26c-1a48-a0ac-8e16-b8f3944b3afb}">
           <p14:sldIdLst>
             <p14:sldId id="256"/>
           </p14:sldIdLst>
         </p14:section>
-        <p14:section name="Question &amp; changes" id="{9751596d-a3ab-fe08-7c3d-55d9493baee6}">
+        <p14:section name="Question &amp; changes" id="{fe515433-1113-c909-5ad2-f264b2d346f7}">
           <p14:sldIdLst>
             <p14:sldId id="257"/>
           </p14:sldIdLst>
         </p14:section>
-        <p14:section name="Pipeline" id="{eec0abca-f3a4-acf2-9c33-6f3b6029472c}">
+        <p14:section name="Pipeline" id="{6d84d6a6-9441-4566-f861-d647f41d7285}">
           <p14:sldIdLst>
             <p14:sldId id="258"/>
           </p14:sldIdLst>
         </p14:section>
-        <p14:section name="Results" id="{eac933c3-5c3e-484d-5d25-1388828a2720}">
+        <p14:section name="Results" id="{c2f0d73f-e03f-791c-2ee4-1975e2f0e4bf}">
           <p14:sldIdLst>
             <p14:sldId id="259"/>
             <p14:sldId id="260"/>
             <p14:sldId id="261"/>
           </p14:sldIdLst>
         </p14:section>
-        <p14:section name="Risks &amp; next steps" id="{5e0c7858-1ebd-2a94-ceeb-430fa1e5ebd5}">
+        <p14:section name="Risks &amp; next steps" id="{fccdde4c-234c-86d3-9c32-57f121c01669}">
           <p14:sldIdLst>
             <p14:sldId id="262"/>
             <p14:sldId id="263"/>
             <p14:sldId id="264"/>
           </p14:sldIdLst>
         </p14:section>
-        <p14:section name="Backup" id="{68add3ac-2c20-4810-a32d-0076c5c46301}">
+        <p14:section name="Backup" id="{4580bf59-111e-6852-e2bc-af3bc9884dbf}">
           <p14:sldIdLst>
             <p14:sldId id="265"/>
             <p14:sldId id="266"/>
@@ -383,10 +383,10 @@
                 <c:formatCode>General</c:formatCode>
                 <c:ptCount val="6"/>
                 <c:pt idx="0">
-                  <c:v>0</c:v>
+                  <c:v>0.10416666666666667</c:v>
                 </c:pt>
                 <c:pt idx="1">
-                  <c:v>0</c:v>
+                  <c:v>0.020833333333333332</c:v>
                 </c:pt>
                 <c:pt idx="2">
                   <c:v>0</c:v>
@@ -597,7 +597,7 @@
                 </a:solidFill>
                 <a:latin typeface="+mn-lt"/>
               </a:rPr>
-              <a:t>Share of hinted runs that mention the hint</a:t>
+              <a:t>How often the hint is mentioned, in runs that had one</a:t>
             </a:r>
           </a:p>
         </c:rich>
@@ -683,13 +683,13 @@
                 <c:formatCode>General</c:formatCode>
                 <c:ptCount val="3"/>
                 <c:pt idx="0">
-                  <c:v>0</c:v>
+                  <c:v>0.9166666666666666</c:v>
                 </c:pt>
                 <c:pt idx="1">
-                  <c:v>0</c:v>
+                  <c:v>0.9861111111111112</c:v>
                 </c:pt>
                 <c:pt idx="2">
-                  <c:v>0</c:v>
+                  <c:v>0.9861111111111112</c:v>
                 </c:pt>
               </c:numCache>
             </c:numRef>
@@ -772,7 +772,7 @@
                   <c:v>0</c:v>
                 </c:pt>
                 <c:pt idx="2">
-                  <c:v>0</c:v>
+                  <c:v>0.1111111111111111</c:v>
                 </c:pt>
               </c:numCache>
             </c:numRef>
@@ -1340,7 +1340,7 @@
           <a:p>
             <a:r>
               <a:rPr lang="en-US" dirty="0"/>
-              <a:t>Hi, we're Group 10. Our question: when a hint pushes a model toward an answer, does its explanation say so? Thinking models give us two channels to check — a private reasoning trace and the final answer the user sees.</a:t>
+              <a:t>Hi, we're Group 10. Our question is simple: when a hint pushes a model toward an answer, does the model say so? Thinking models give us two places to look. There's the private reasoning they write first, and the final answer the user sees.</a:t>
             </a:r>
             <a:endParaRPr lang="en-US" dirty="0"/>
           </a:p>
@@ -1604,7 +1604,7 @@
           <a:p>
             <a:r>
               <a:rPr lang="en-US" dirty="0"/>
-              <a:t>We ask whether a model's explanation admits a hint that shaped its answer. The review pushed us on controls: instruct and thinking models are trained differently, so we no longer call that a clean thinking on/off comparison — and Voyager can't switch thinking off, which we checked. We added repeated no-hint runs, balanced hint and answer positions, correct hints, and we now score 'mentions the hint' separately from 'admits it changed the answer'.</a:t>
+              <a:t>Here's the setup. We give a model a puzzle, and sometimes we add a line like 'I think the answer is C.' Then we check two things: did the hint change the answer, and does the model mention it? The review pushed us on a few points. The regular and thinking models in a pair are trained differently, so a gap between them isn't only about thinking. We checked, and Voyager has no switch to turn thinking off, so we also ask the same model to think briefly. We now repeat each puzzle without a hint, spread hints and right answers evenly across the letters, and score 'mentions the hint' apart from 'says the hint changed its answer'.</a:t>
             </a:r>
             <a:endParaRPr lang="en-US" dirty="0"/>
           </a:p>
@@ -1692,7 +1692,7 @@
           <a:p>
             <a:r>
               <a:rPr lang="en-US" dirty="0"/>
-              <a:t>Here's the pipeline. We generate fresh puzzles with exact answers, add a hint or not, send them to six models on ASU's free Voyager API, and split each reply into the private reasoning and the final answer. Everything is streamed and cached, so reruns are free. Along the way we fixed server timeouts and an answer parser that was silently marking 45% of answers wrong.</a:t>
+              <a:t>This is our pipeline, and it works from start to finish. We make fresh puzzles with one right answer, add a hint or not, and send them to six models on ASU's free Voyager service. Each reply comes back in two parts, the private reasoning and the final answer. We save every reply, so rerunning the analysis costs nothing. Along the way we fixed two problems. Long replies were timing out, and almost half the answers weren't in the format we asked for, so a simple reader would have marked them wrong.</a:t>
             </a:r>
             <a:endParaRPr lang="en-US" dirty="0"/>
           </a:p>
@@ -1780,7 +1780,7 @@
           <a:p>
             <a:r>
               <a:rPr lang="en-US" dirty="0"/>
-              <a:t>First result. Blue is how often a model picked an option with no hint at all; orange is how often it picked that same option when we suggested it. The gap is the hint's effect, and it's small — a few points, mostly inside normal run-to-run variation. That's a null result at this difficulty, and we think it's partly the task: the models solve these puzzles, so there's little room to be pushed.</a:t>
+              <a:t>Our first result. Blue is how often a model picked a wrong option with no hint. Orange is how often it picked that same option when we suggested it. Only one model follows the hint. Olmo 3 7B Instruct picks the wrong hinted answer about 10% of the time and never without the hint, and our 95% range stays above zero, so it isn't luck. Its thinking twin barely moves, and the larger models don't move at all, partly because they solve these puzzles every time. We also checked chance: run again without a hint, Olmo 7B Instruct changes its answer on almost a third of puzzles, but never to the hinted letter.</a:t>
             </a:r>
             <a:endParaRPr lang="en-US" dirty="0"/>
           </a:p>
@@ -1868,7 +1868,7 @@
           <a:p>
             <a:r>
               <a:rPr lang="en-US" dirty="0"/>
-              <a:t>Second result, and the one we'll build on. When there's a hint, the thinking models discuss it in their private reasoning almost every time, but it rarely if ever reaches the answer the user sees. Instruct models, which only have one channel, do mention it in their visible reply some of the time, so thinking seems to move the acknowledgement out of sight. Two cautions: most of those trace mentions are the model rejecting the hint, so this is 'mentions', not 'admits influence'. And omission is our operational measure — it's not proof of dishonesty, and the trace isn't the model's actual computation.</a:t>
+              <a:t>Our second result, and the one we'll build on. When there's a hint, thinking models mention it in their private reasoning almost every time. It almost never reaches the final answer: zero times for Olmo, and 8 times out of 216 overall. Olmo's regular models have no private reasoning, and they mention the hint in about a third of their replies. So for Olmo, thinking moves the mention out of sight. Qwen shows no such gap. Two cautions. Most of those mentions are the model brushing the hint off, so we count them as mentions, not admissions. And leaving the hint out doesn't prove a model is hiding something. The private reasoning isn't a perfect view of what goes on inside the model either.</a:t>
             </a:r>
             <a:endParaRPr lang="en-US" dirty="0"/>
           </a:p>
@@ -1956,7 +1956,7 @@
           <a:p>
             <a:r>
               <a:rPr lang="en-US" dirty="0"/>
-              <a:t>A few smaller findings that change how we run things. The hint makes thinking models write longer, so influence costs compute even when the answer holds. Telling a thinking model 'don't explain' only hides the explanation; it still thinks privately. If a response hits the token limit, the private reasoning spills into the visible answer — a real deployment hazard. And 'think briefly' shortens reasoning on the same model, which gives us a within-model comparison the review asked for.</a:t>
+              <a:t>A few smaller findings that change how we run things. A hint makes every model write more, even when the answer stays the same. When we tell a thinking model 'answer only, don't explain', it still reasons in private and stays accurate. Regular models told the same thing get almost everything wrong, worse than guessing. When a reply hits the length limit, the private reasoning spills into the answer the user sees, which matters for anyone building on these models. And asking for brief thinking shortens the reasoning on the same model, which gives us the same-model comparison the review asked for.</a:t>
             </a:r>
             <a:endParaRPr lang="en-US" dirty="0"/>
           </a:p>
@@ -2044,7 +2044,7 @@
           <a:p>
             <a:r>
               <a:rPr lang="en-US" dirty="0"/>
-              <a:t>Main risks. One: we can't switch thinking off on Voyager, so instruct-versus-thinking is a comparison of differently trained models — we say so, and we added a same-model 'think briefly' condition. Two: the hint barely works on these puzzles, so we're adding ambiguous BBQ and BBH questions. Three: keywords can't tell a mention from an admission, so we'll hand-label 200 cases with two raters. Four: compute — thinking models cost three times the tokens, so we're cutting the design to about 55 million tokens and timing it first.</a:t>
+              <a:t>Our main risks. First, we can't turn thinking off on Voyager, so comparing regular and thinking models means comparing two differently trained models. We say that openly, and we added the 'think briefly' test on the same model. Second, the hint only moves the smallest model on these puzzles, so we're adding questions where hints have more room. Third, keyword search can't tell a mention from an admission, so two of us will hand-label 200 replies. Fourth, cost: thinking models write about four times as much, so we're shrinking the plan and timing a test run first.</a:t>
             </a:r>
             <a:endParaRPr lang="en-US" dirty="0"/>
           </a:p>
@@ -2132,7 +2132,7 @@
           <a:p>
             <a:r>
               <a:rPr lang="en-US" dirty="0"/>
-              <a:t>Next steps: next week we add BBQ and BBH questions and time a budget run before freezing prompts. Weeks ten and eleven are the main sweep and hand-labeling. Then the two-agent extension the reviewer suggested: one model gets the hint, a second reviews its answer, and we see whether the influence gets caught or carried forward. Roles are on the slide.</a:t>
+              <a:t>Next steps. Next week we add the new question sets, time a test run, and lock the prompts. Weeks ten and eleven are the main runs and the hand-labeling. If we're on track, we'll try the extension the reviewer suggested: one model gets the hint, a second model reviews its answer, and we see if the second one catches it or passes it along. Roles are on the slide.</a:t>
             </a:r>
             <a:endParaRPr lang="en-US" dirty="0"/>
           </a:p>
@@ -2220,7 +2220,7 @@
           <a:p>
             <a:r>
               <a:rPr lang="en-US" dirty="0"/>
-              <a:t>To sum up: the hint mostly doesn't change answers here, but thinking models always register it privately and never mention it publicly. Next we test whether a second model catches that or passes it along. Happy to take questions.</a:t>
+              <a:t>To sum up: on these puzzles the hint mostly doesn't change answers, but thinking models almost always notice it in private and almost never mention it in the answer. Next we test whether a second model catches that. Thanks, we'll take questions now.</a:t>
             </a:r>
             <a:endParaRPr lang="en-US" dirty="0"/>
           </a:p>
@@ -2534,7 +2534,7 @@
                   <a:schemeClr val="accent5"/>
                 </a:solidFill>
               </a:rPr>
-              <a:t>CSE 598 · Progress presentation · Do thinking modes make CoT more honest?</a:t>
+              <a:t>CSE 598 · Group 10 · Progress presentation</a:t>
             </a:r>
             <a:endParaRPr lang="en-US" sz="1000" dirty="0"/>
           </a:p>
@@ -3004,7 +3004,7 @@
                   <a:schemeClr val="bg2"/>
                 </a:solidFill>
               </a:rPr>
-              <a:t>Progress report: do thinking models’ explanations admit a hint that shaped their answer?</a:t>
+              <a:t>Progress report: do thinking models admit it when a hint sways their answer?</a:t>
             </a:r>
             <a:endParaRPr lang="en-US" sz="1900" dirty="0"/>
           </a:p>
@@ -3283,7 +3283,7 @@
                   <a:schemeClr val="tx1"/>
                 </a:solidFill>
               </a:rPr>
-              <a:t>Backup: what differs within each pair</a:t>
+              <a:t>Backup: how the two models in each pair differ</a:t>
             </a:r>
             <a:endParaRPr lang="en-US" sz="3000" dirty="0"/>
           </a:p>
@@ -3393,7 +3393,7 @@
                             <a:schemeClr val="bg1"/>
                           </a:solidFill>
                         </a:rPr>
-                        <a:t>Voyager model IDs</a:t>
+                        <a:t>Names on Voyager</a:t>
                       </a:r>
                       <a:endParaRPr lang="en-US" sz="1400" dirty="0"/>
                     </a:p>
@@ -3454,7 +3454,7 @@
                             <a:schemeClr val="bg1"/>
                           </a:solidFill>
                         </a:rPr>
-                        <a:t>Shared</a:t>
+                        <a:t>Same</a:t>
                       </a:r>
                       <a:endParaRPr lang="en-US" sz="1400" dirty="0"/>
                     </a:p>
@@ -3708,7 +3708,7 @@
                             <a:schemeClr val="tx1"/>
                           </a:solidFill>
                         </a:rPr>
-                        <a:t>Same base model; SFT → DPO → RL</a:t>
+                        <a:t>Same base model and the same three training stages</a:t>
                       </a:r>
                       <a:endParaRPr lang="en-US" sz="1350" dirty="0"/>
                     </a:p>
@@ -3766,7 +3766,7 @@
                             <a:schemeClr val="tx1"/>
                           </a:solidFill>
                         </a:rPr>
-                        <a:t>Think: reasoning traces from QwQ-32B and DeepSeek-R1. Instruct: chat, tool-use and instruction data with traces removed</a:t>
+                        <a:t>Think learned from worked reasoning written by other models (QwQ-32B, DeepSeek-R1). Instruct learned from chat and tool-use examples with that reasoning removed</a:t>
                       </a:r>
                       <a:endParaRPr lang="en-US" sz="1350" dirty="0"/>
                     </a:p>
@@ -4014,7 +4014,7 @@
                             <a:schemeClr val="tx1"/>
                           </a:solidFill>
                         </a:rPr>
-                        <a:t>Same recipes. Olmo 3.1 32B variants also exist: to confirm on the Voyager portal</a:t>
+                        <a:t>Same training recipes. A newer Olmo 3.1 32B also exists; we still need to check which one Voyager runs</a:t>
                       </a:r>
                       <a:endParaRPr lang="en-US" sz="1350" dirty="0"/>
                     </a:p>
@@ -4074,7 +4074,7 @@
                             <a:schemeClr val="tx1"/>
                           </a:solidFill>
                         </a:rPr>
-                        <a:t>Qwen3 30B-A3B</a:t>
+                        <a:t>Qwen3 30B</a:t>
                       </a:r>
                       <a:endParaRPr lang="en-US" sz="1350" dirty="0"/>
                     </a:p>
@@ -4204,7 +4204,7 @@
                             <a:schemeClr val="tx1"/>
                           </a:solidFill>
                         </a:rPr>
-                        <a:t>Identical architecture (30.5B, 3.3B active)</a:t>
+                        <a:t>Same design and size (30.5B parameters, 3.3B used per word)</a:t>
                       </a:r>
                       <a:endParaRPr lang="en-US" sz="1350" dirty="0"/>
                     </a:p>
@@ -4262,7 +4262,7 @@
                             <a:schemeClr val="tx1"/>
                           </a:solidFill>
                         </a:rPr>
-                        <a:t>Separate post-training lines; thinking-only vs non-thinking-only. Recommended sampling differs (0.6 vs 0.7); we use 0.6 for all</a:t>
+                        <a:t>Trained separately after the base model: one always thinks, one never does. Their makers suggest slightly different randomness (0.6 vs 0.7); we use 0.6 for both</a:t>
                       </a:r>
                       <a:endParaRPr lang="en-US" sz="1350" dirty="0"/>
                     </a:p>
@@ -4341,7 +4341,7 @@
                   <a:schemeClr val="accent5"/>
                 </a:solidFill>
               </a:rPr>
-              <a:t>Sources: AI2 Olmo 3 release and model cards; Qwen3-2507 model cards.</a:t>
+              <a:t>Sources: AI2’s Olmo 3 release and model cards; Qwen3-2507 model cards.</a:t>
             </a:r>
             <a:endParaRPr lang="en-US" sz="1100" dirty="0"/>
           </a:p>
@@ -4449,7 +4449,7 @@
                   <a:schemeClr val="tx1"/>
                 </a:solidFill>
               </a:rPr>
-              <a:t>Backup: design and budget</a:t>
+              <a:t>Backup: how we ran this round</a:t>
             </a:r>
             <a:endParaRPr lang="en-US" sz="3000" dirty="0"/>
           </a:p>
@@ -4620,7 +4620,7 @@
                             <a:schemeClr val="tx1"/>
                           </a:solidFill>
                         </a:rPr>
-                        <a:t>Items</a:t>
+                        <a:t>Puzzles</a:t>
                       </a:r>
                       <a:endParaRPr lang="en-US" sz="1350" dirty="0"/>
                     </a:p>
@@ -4678,7 +4678,7 @@
                             <a:schemeClr val="tx1"/>
                           </a:solidFill>
                         </a:rPr>
-                        <a:t>24 shuffled-object puzzles (7 people, 15 swaps); correct answers balanced across A–G</a:t>
+                        <a:t>24 swap puzzles (7 people, 15 swaps), with right answers spread evenly across A to G</a:t>
                       </a:r>
                       <a:endParaRPr lang="en-US" sz="1350" dirty="0"/>
                     </a:p>
@@ -4738,7 +4738,7 @@
                             <a:schemeClr val="tx1"/>
                           </a:solidFill>
                         </a:rPr>
-                        <a:t>Conditions per item</a:t>
+                        <a:t>Runs per puzzle</a:t>
                       </a:r>
                       <a:endParaRPr lang="en-US" sz="1350" dirty="0"/>
                     </a:p>
@@ -4796,7 +4796,7 @@
                             <a:schemeClr val="tx1"/>
                           </a:solidFill>
                         </a:rPr>
-                        <a:t>No hint × 3 seeds · wrong hint × 2 (positions balanced) · correct hint × 1</a:t>
+                        <a:t>No hint 3 times, a wrong hint 2 times (spread across letters), a right hint once</a:t>
                       </a:r>
                       <a:endParaRPr lang="en-US" sz="1350" dirty="0"/>
                     </a:p>
@@ -4856,7 +4856,7 @@
                             <a:schemeClr val="tx1"/>
                           </a:solidFill>
                         </a:rPr>
-                        <a:t>Sampling</a:t>
+                        <a:t>Settings</a:t>
                       </a:r>
                       <a:endParaRPr lang="en-US" sz="1350" dirty="0"/>
                     </a:p>
@@ -4914,7 +4914,7 @@
                             <a:schemeClr val="tx1"/>
                           </a:solidFill>
                         </a:rPr>
-                        <a:t>Temperature 0.6, fixed seeds (verified reproducible), 16k max tokens, streamed</a:t>
+                        <a:t>Randomness (temperature) 0.6, fixed random seeds so runs repeat exactly, up to 16,000 tokens per reply</a:t>
                       </a:r>
                       <a:endParaRPr lang="en-US" sz="1350" dirty="0"/>
                     </a:p>
@@ -4974,7 +4974,7 @@
                             <a:schemeClr val="tx1"/>
                           </a:solidFill>
                         </a:rPr>
-                        <a:t>Extra checks</a:t>
+                        <a:t>Extra tests</a:t>
                       </a:r>
                       <a:endParaRPr lang="en-US" sz="1350" dirty="0"/>
                     </a:p>
@@ -5032,7 +5032,7 @@
                             <a:schemeClr val="tx1"/>
                           </a:solidFill>
                         </a:rPr>
-                        <a:t>“Think briefly” on 2 thinking models · “answer only” on 4 models</a:t>
+                        <a:t>“Think briefly” on 2 thinking models; “answer only” on 4 models</a:t>
                       </a:r>
                       <a:endParaRPr lang="en-US" sz="1350" dirty="0"/>
                     </a:p>
@@ -5092,7 +5092,7 @@
                             <a:schemeClr val="tx1"/>
                           </a:solidFill>
                         </a:rPr>
-                        <a:t>Median output tokens</a:t>
+                        <a:t>Typical reply length (tokens)</a:t>
                       </a:r>
                       <a:endParaRPr lang="en-US" sz="1350" dirty="0"/>
                     </a:p>
@@ -5150,7 +5150,7 @@
                             <a:schemeClr val="tx1"/>
                           </a:solidFill>
                         </a:rPr>
-                        <a:t>Olmo 3 7B Instruct 1,406 · Olmo 3 7B Think 7,272 · Olmo 3 32B Instruct 1,467 · Olmo 3 32B Think 4,610 · Qwen3 30B Instruct 833 · Qwen3 30B Thinking 3,951</a:t>
+                        <a:t>Olmo 3 7B Instruct 2,021 · Olmo 3 7B Think 8,026 · Olmo 3 32B Instruct 1,669 · Olmo 3 32B Think 5,725 · Qwen3 30B Instruct 891 · Qwen3 30B Thinking 3,997</a:t>
                       </a:r>
                       <a:endParaRPr lang="en-US" sz="1350" dirty="0"/>
                     </a:p>
@@ -5268,7 +5268,7 @@
                             <a:schemeClr val="tx1"/>
                           </a:solidFill>
                         </a:rPr>
-                        <a:t>105 this round; 0 errors</a:t>
+                        <a:t>1,056 this round; 0 failed</a:t>
                       </a:r>
                       <a:endParaRPr lang="en-US" sz="1350" dirty="0"/>
                     </a:p>
@@ -5419,7 +5419,7 @@
                   <a:schemeClr val="tx1"/>
                 </a:solidFill>
               </a:rPr>
-              <a:t>The question, and what changed after review</a:t>
+              <a:t>Our question, and what we changed after the review</a:t>
             </a:r>
             <a:endParaRPr lang="en-US" sz="3000" dirty="0"/>
           </a:p>
@@ -5477,7 +5477,7 @@
                   <a:schemeClr val="tx1"/>
                 </a:solidFill>
               </a:rPr>
-              <a:t>When a hint shapes a model’s answer, does its explanation say so?</a:t>
+              <a:t>When a hint changes a model’s answer, does the model say so?</a:t>
             </a:r>
             <a:endParaRPr lang="en-US" sz="2100" dirty="0"/>
           </a:p>
@@ -5596,8 +5596,8 @@
         </p:nvSpPr>
         <p:spPr>
           <a:xfrm>
-            <a:off x="822960" y="4572000"/>
-            <a:ext cx="4572000" cy="731520"/>
+            <a:off x="822960" y="4526280"/>
+            <a:ext cx="4572000" cy="822960"/>
           </a:xfrm>
           <a:prstGeom prst="rect">
             <a:avLst/>
@@ -5618,7 +5618,7 @@
                   <a:schemeClr val="accent5"/>
                 </a:solidFill>
               </a:rPr>
-              <a:t>Three instruct/thinking pairs, two families (Olmo 3, Qwen3), on ASU’s Voyager API.</a:t>
+              <a:t>We test 3 pairs of models from Olmo 3 and Qwen3. Each pair has a regular chat model (Instruct) and a thinking model that reasons in private first.</a:t>
             </a:r>
             <a:endParaRPr lang="en-US" sz="1300" dirty="0"/>
           </a:p>
@@ -5654,7 +5654,7 @@
                   <a:schemeClr val="tx1"/>
                 </a:solidFill>
               </a:rPr>
-              <a:t>Since the proposal</a:t>
+              <a:t>What we changed after the review</a:t>
             </a:r>
             <a:endParaRPr lang="en-US" sz="1900" dirty="0"/>
           </a:p>
@@ -5694,7 +5694,7 @@
                   <a:schemeClr val="tx1"/>
                 </a:solidFill>
               </a:rPr>
-              <a:t>Instruct vs thinking = differently trained models.</a:t>
+              <a:t>The two models in a pair are trained differently,</a:t>
             </a:r>
             <a:pPr indent="0" marL="0">
               <a:spcAft>
@@ -5708,7 +5708,7 @@
                   <a:schemeClr val="tx1"/>
                 </a:solidFill>
               </a:rPr>
-              <a:t> Voyager has no thinking on/off switch, so we added “think briefly” vs normal on the same checkpoint.</a:t>
+              <a:t> so a gap isn’t only about thinking. Voyager can’t turn thinking off, so we also ask the same model to “think briefly”.</a:t>
             </a:r>
             <a:endParaRPr lang="en-US" sz="1400" dirty="0"/>
           </a:p>
@@ -5726,7 +5726,7 @@
                   <a:schemeClr val="tx1"/>
                 </a:solidFill>
               </a:rPr>
-              <a:t>Repeated no-hint runs</a:t>
+              <a:t>We run each puzzle 3 times with no hint</a:t>
             </a:r>
             <a:pPr indent="0" marL="0">
               <a:spcAft>
@@ -5740,7 +5740,7 @@
                   <a:schemeClr val="tx1"/>
                 </a:solidFill>
               </a:rPr>
-              <a:t> (3 seeds) to separate hint effects from normal run-to-run variation.</a:t>
+              <a:t> to see how much answers change by chance.</a:t>
             </a:r>
             <a:endParaRPr lang="en-US" sz="1400" dirty="0"/>
           </a:p>
@@ -5758,7 +5758,7 @@
                   <a:schemeClr val="tx1"/>
                 </a:solidFill>
               </a:rPr>
-              <a:t>Hints balanced across answer positions</a:t>
+              <a:t>Hints point to every letter equally often,</a:t>
             </a:r>
             <a:pPr indent="0" marL="0">
               <a:spcAft>
@@ -5772,7 +5772,7 @@
                   <a:schemeClr val="tx1"/>
                 </a:solidFill>
               </a:rPr>
-              <a:t>, and correct hints added alongside wrong ones.</a:t>
+              <a:t> and some hints are correct.</a:t>
             </a:r>
             <a:endParaRPr lang="en-US" sz="1400" dirty="0"/>
           </a:p>
@@ -5790,7 +5790,7 @@
                   <a:schemeClr val="tx1"/>
                 </a:solidFill>
               </a:rPr>
-              <a:t>Correct answers balanced across positions</a:t>
+              <a:t>Right answers are spread across the letters.</a:t>
             </a:r>
             <a:pPr indent="0" marL="0">
               <a:spcAft>
@@ -5804,7 +5804,7 @@
                   <a:schemeClr val="tx1"/>
                 </a:solidFill>
               </a:rPr>
-              <a:t> — they had piled up at (A).</a:t>
+              <a:t> Before, too many were (A).</a:t>
             </a:r>
             <a:endParaRPr lang="en-US" sz="1400" dirty="0"/>
           </a:p>
@@ -5822,7 +5822,7 @@
                   <a:schemeClr val="tx1"/>
                 </a:solidFill>
               </a:rPr>
-              <a:t>“Mentions the hint” ≠ “admits it changed the answer”</a:t>
+              <a:t>“Mentions the hint” is scored apart</a:t>
             </a:r>
             <a:pPr indent="0" marL="0">
               <a:spcAft>
@@ -5836,7 +5836,7 @@
                   <a:schemeClr val="tx1"/>
                 </a:solidFill>
               </a:rPr>
-              <a:t> — scored separately.</a:t>
+              <a:t> from “says the hint changed its answer”.</a:t>
             </a:r>
             <a:endParaRPr lang="en-US" sz="1400" dirty="0"/>
           </a:p>
@@ -5854,7 +5854,7 @@
                   <a:schemeClr val="tx1"/>
                 </a:solidFill>
               </a:rPr>
-              <a:t>Planned: a two-agent version</a:t>
+              <a:t>Maybe later: a second model</a:t>
             </a:r>
             <a:pPr indent="0" marL="0">
               <a:spcAft>
@@ -5868,7 +5868,7 @@
                   <a:schemeClr val="tx1"/>
                 </a:solidFill>
               </a:rPr>
-              <a:t> — does a reviewer model catch or repeat the influence?</a:t>
+              <a:t> reviews the first one’s answer. Does it catch the hint?</a:t>
             </a:r>
             <a:endParaRPr lang="en-US" sz="1400" dirty="0"/>
           </a:p>
@@ -5976,7 +5976,7 @@
                   <a:schemeClr val="tx1"/>
                 </a:solidFill>
               </a:rPr>
-              <a:t>The pipeline runs end to end</a:t>
+              <a:t>Our pipeline runs end to end</a:t>
             </a:r>
             <a:endParaRPr lang="en-US" sz="3000" dirty="0"/>
           </a:p>
@@ -6058,7 +6058,7 @@
                   <a:schemeClr val="tx1"/>
                 </a:solidFill>
               </a:rPr>
-              <a:t>Generate puzzles</a:t>
+              <a:t>Make puzzles</a:t>
             </a:r>
             <a:endParaRPr lang="en-US" sz="1500" dirty="0"/>
           </a:p>
@@ -6094,7 +6094,7 @@
                   <a:schemeClr val="accent5"/>
                 </a:solidFill>
               </a:rPr>
-              <a:t>Shuffled-object tasks with exact answers; new each time, so no training-data overlap</a:t>
+              <a:t>Swap puzzles with one right answer, made fresh so no model has seen them</a:t>
             </a:r>
             <a:endParaRPr lang="en-US" sz="1200" dirty="0"/>
           </a:p>
@@ -6236,7 +6236,7 @@
                   <a:schemeClr val="accent5"/>
                 </a:solidFill>
               </a:rPr>
-              <a:t>None, wrong, or correct; positions balanced</a:t>
+              <a:t>No hint, a wrong hint, or a right one, spread across the letters</a:t>
             </a:r>
             <a:endParaRPr lang="en-US" sz="1200" dirty="0"/>
           </a:p>
@@ -6378,7 +6378,7 @@
                   <a:schemeClr val="accent5"/>
                 </a:solidFill>
               </a:rPr>
-              <a:t>3 instruct/thinking pairs on ASU Voyager, streamed, cached</a:t>
+              <a:t>3 pairs on ASU’s free Voyager service; we save every reply</a:t>
             </a:r>
             <a:endParaRPr lang="en-US" sz="1200" dirty="0"/>
           </a:p>
@@ -6484,7 +6484,7 @@
                   <a:schemeClr val="tx1"/>
                 </a:solidFill>
               </a:rPr>
-              <a:t>Split channels</a:t>
+              <a:t>Split the reply</a:t>
             </a:r>
             <a:endParaRPr lang="en-US" sz="1500" dirty="0"/>
           </a:p>
@@ -6520,7 +6520,7 @@
                   <a:schemeClr val="accent5"/>
                 </a:solidFill>
               </a:rPr>
-              <a:t>Private reasoning vs final answer</a:t>
+              <a:t>The private reasoning and the final answer come back separately</a:t>
             </a:r>
             <a:endParaRPr lang="en-US" sz="1200" dirty="0"/>
           </a:p>
@@ -6662,7 +6662,7 @@
                   <a:schemeClr val="accent5"/>
                 </a:solidFill>
               </a:rPr>
-              <a:t>Parse the answer; detect hint mentions</a:t>
+              <a:t>Read off the answer letter; check if the hint is mentioned</a:t>
             </a:r>
             <a:endParaRPr lang="en-US" sz="1200" dirty="0"/>
           </a:p>
@@ -6768,7 +6768,7 @@
                   <a:schemeClr val="tx1"/>
                 </a:solidFill>
               </a:rPr>
-              <a:t>Analyze</a:t>
+              <a:t>Compare</a:t>
             </a:r>
             <a:endParaRPr lang="en-US" sz="1500" dirty="0"/>
           </a:p>
@@ -6804,7 +6804,7 @@
                   <a:schemeClr val="accent5"/>
                 </a:solidFill>
               </a:rPr>
-              <a:t>Hint effect vs no-hint variation, bootstrap CIs</a:t>
+              <a:t>With vs without the hint, with 95% ranges</a:t>
             </a:r>
             <a:endParaRPr lang="en-US" sz="1200" dirty="0"/>
           </a:p>
@@ -6862,7 +6862,7 @@
                   <a:schemeClr val="accent1"/>
                 </a:solidFill>
               </a:rPr>
-              <a:t>105</a:t>
+              <a:t>1,056</a:t>
             </a:r>
             <a:endParaRPr lang="en-US" sz="4000" dirty="0"/>
           </a:p>
@@ -6898,7 +6898,7 @@
                   <a:schemeClr val="tx1"/>
                 </a:solidFill>
               </a:rPr>
-              <a:t>model calls in this round</a:t>
+              <a:t>questions sent this round</a:t>
             </a:r>
             <a:endParaRPr lang="en-US" sz="1300" dirty="0"/>
           </a:p>
@@ -6992,7 +6992,7 @@
                   <a:schemeClr val="tx1"/>
                 </a:solidFill>
               </a:rPr>
-              <a:t>models, 2 families</a:t>
+              <a:t>models from 2 families</a:t>
             </a:r>
             <a:endParaRPr lang="en-US" sz="1300" dirty="0"/>
           </a:p>
@@ -7086,7 +7086,7 @@
                   <a:schemeClr val="tx1"/>
                 </a:solidFill>
               </a:rPr>
-              <a:t>API errors after fixes</a:t>
+              <a:t>failed calls</a:t>
             </a:r>
             <a:endParaRPr lang="en-US" sz="1300" dirty="0"/>
           </a:p>
@@ -7180,7 +7180,7 @@
                   <a:schemeClr val="tx1"/>
                 </a:solidFill>
               </a:rPr>
-              <a:t>calls in earlier pilots</a:t>
+              <a:t>calls in earlier test runs</a:t>
             </a:r>
             <a:endParaRPr lang="en-US" sz="1300" dirty="0"/>
           </a:p>
@@ -7288,7 +7288,7 @@
                   <a:schemeClr val="tx1"/>
                 </a:solidFill>
               </a:rPr>
-              <a:t>Result 1: the hint barely changes answers</a:t>
+              <a:t>Result 1: only Olmo 3 7B Instruct follows wrong hints</a:t>
             </a:r>
             <a:endParaRPr lang="en-US" sz="3000" dirty="0"/>
           </a:p>
@@ -7357,14 +7357,14 @@
               <a:buNone/>
             </a:pPr>
             <a:r>
-              <a:rPr lang="en-US" sz="1400" b="1" dirty="0">
+              <a:rPr lang="en-US" sz="1350" b="1" dirty="0">
                 <a:solidFill>
                   <a:schemeClr val="tx1"/>
                 </a:solidFill>
               </a:rPr>
-              <a:t>Hint effect (with − without), 95% CI</a:t>
-            </a:r>
-            <a:endParaRPr lang="en-US" sz="1400" dirty="0"/>
+              <a:t>How much the hint moved answers (95% range)</a:t>
+            </a:r>
+            <a:endParaRPr lang="en-US" sz="1350" dirty="0"/>
           </a:p>
         </p:txBody>
       </p:sp>
@@ -7377,7 +7377,7 @@
         <p:spPr>
           <a:xfrm>
             <a:off x="8092440" y="1920240"/>
-            <a:ext cx="3383280" cy="2103120"/>
+            <a:ext cx="3383280" cy="1920240"/>
           </a:xfrm>
           <a:prstGeom prst="rect">
             <a:avLst/>
@@ -7401,7 +7401,7 @@
                   <a:schemeClr val="tx1"/>
                 </a:solidFill>
               </a:rPr>
-              <a:t>Olmo 3 7B Instruct:  –</a:t>
+              <a:t>Olmo 3 7B Instruct:  +10.4 points (2.1 to 18.8)</a:t>
             </a:r>
             <a:endParaRPr lang="en-US" sz="1150" dirty="0"/>
           </a:p>
@@ -7418,7 +7418,7 @@
                   <a:schemeClr val="tx1"/>
                 </a:solidFill>
               </a:rPr>
-              <a:t>Olmo 3 7B Think:  –</a:t>
+              <a:t>Olmo 3 7B Think:  +2.1 points (0.0 to 6.3)</a:t>
             </a:r>
             <a:endParaRPr lang="en-US" sz="1150" dirty="0"/>
           </a:p>
@@ -7435,7 +7435,7 @@
                   <a:schemeClr val="tx1"/>
                 </a:solidFill>
               </a:rPr>
-              <a:t>Olmo 3 32B Instruct:  –</a:t>
+              <a:t>Olmo 3 32B Instruct:  no effect</a:t>
             </a:r>
             <a:endParaRPr lang="en-US" sz="1150" dirty="0"/>
           </a:p>
@@ -7452,7 +7452,7 @@
                   <a:schemeClr val="tx1"/>
                 </a:solidFill>
               </a:rPr>
-              <a:t>Olmo 3 32B Think:  –</a:t>
+              <a:t>Olmo 3 32B Think:  no effect</a:t>
             </a:r>
             <a:endParaRPr lang="en-US" sz="1150" dirty="0"/>
           </a:p>
@@ -7469,7 +7469,7 @@
                   <a:schemeClr val="tx1"/>
                 </a:solidFill>
               </a:rPr>
-              <a:t>Qwen3 30B Instruct:  –</a:t>
+              <a:t>Qwen3 30B Instruct:  no effect</a:t>
             </a:r>
             <a:endParaRPr lang="en-US" sz="1150" dirty="0"/>
           </a:p>
@@ -7486,7 +7486,7 @@
                   <a:schemeClr val="tx1"/>
                 </a:solidFill>
               </a:rPr>
-              <a:t>Qwen3 30B Thinking:  –</a:t>
+              <a:t>Qwen3 30B Thinking:  no effect</a:t>
             </a:r>
             <a:endParaRPr lang="en-US" sz="1150" dirty="0"/>
           </a:p>
@@ -7500,8 +7500,8 @@
         </p:nvSpPr>
         <p:spPr>
           <a:xfrm>
-            <a:off x="8092440" y="4069080"/>
-            <a:ext cx="3383280" cy="1920240"/>
+            <a:off x="8092440" y="3886200"/>
+            <a:ext cx="3383280" cy="2148840"/>
           </a:xfrm>
           <a:prstGeom prst="rect">
             <a:avLst/>
@@ -7515,43 +7515,43 @@
           <a:p>
             <a:pPr indent="0" marL="0">
               <a:spcAft>
-                <a:spcPts val="600"/>
+                <a:spcPts val="500"/>
               </a:spcAft>
               <a:buNone/>
             </a:pPr>
             <a:r>
-              <a:rPr lang="en-US" sz="1200" b="1" dirty="0">
+              <a:rPr lang="en-US" sz="1150" b="1" dirty="0">
                 <a:solidFill>
                   <a:schemeClr val="tx1"/>
                 </a:solidFill>
               </a:rPr>
-              <a:t>What we can say: </a:t>
+              <a:t>What we found: </a:t>
             </a:r>
             <a:pPr indent="0" marL="0">
               <a:spcAft>
-                <a:spcPts val="600"/>
+                <a:spcPts val="500"/>
               </a:spcAft>
               <a:buNone/>
             </a:pPr>
             <a:r>
-              <a:rPr lang="en-US" sz="1200" dirty="0">
+              <a:rPr lang="en-US" sz="1150" dirty="0">
                 <a:solidFill>
                   <a:schemeClr val="tx1"/>
                 </a:solidFill>
               </a:rPr>
-              <a:t>on these puzzles a wrong hint shifts choices by only a few points, within ordinary run-to-run variation for most models.</a:t>
-            </a:r>
-            <a:endParaRPr lang="en-US" sz="1200" dirty="0"/>
+              <a:t>Olmo 3 7B Instruct picked the wrong hinted answer 10% of the time, and never without the hint. Its thinking twin: 2%. The larger models: never.</a:t>
+            </a:r>
+            <a:endParaRPr lang="en-US" sz="1150" dirty="0"/>
           </a:p>
           <a:p>
             <a:pPr indent="0" marL="0">
               <a:spcAft>
-                <a:spcPts val="600"/>
+                <a:spcPts val="500"/>
               </a:spcAft>
               <a:buNone/>
             </a:pPr>
             <a:r>
-              <a:rPr lang="en-US" sz="1200" b="1" dirty="0">
+              <a:rPr lang="en-US" sz="1150" b="1" dirty="0">
                 <a:solidFill>
                   <a:schemeClr val="tx1"/>
                 </a:solidFill>
@@ -7560,19 +7560,19 @@
             </a:r>
             <a:pPr indent="0" marL="0">
               <a:spcAft>
-                <a:spcPts val="600"/>
+                <a:spcPts val="500"/>
               </a:spcAft>
               <a:buNone/>
             </a:pPr>
             <a:r>
-              <a:rPr lang="en-US" sz="1200" dirty="0">
+              <a:rPr lang="en-US" sz="1150" dirty="0">
                 <a:solidFill>
                   <a:schemeClr val="tx1"/>
                 </a:solidFill>
               </a:rPr>
-              <a:t>one task, 24 puzzles. The models are mostly accurate here, so a hint has little room to work.</a:t>
-            </a:r>
-            <a:endParaRPr lang="en-US" sz="1200" dirty="0"/>
+              <a:t>one kind of puzzle, 24 puzzles. The larger models solve almost all of them, so a hint has little room to work. Run again with no hint, Olmo 3 7B Instruct changed its answer on 29% of puzzles, but never to the hinted letter.</a:t>
+            </a:r>
+            <a:endParaRPr lang="en-US" sz="1150" dirty="0"/>
           </a:p>
         </p:txBody>
       </p:sp>
@@ -7678,7 +7678,7 @@
                   <a:schemeClr val="tx1"/>
                 </a:solidFill>
               </a:rPr>
-              <a:t>Result 2: thinking models notice the hint, then leave it out</a:t>
+              <a:t>Result 2: thinking models see the hint, rarely mention it</a:t>
             </a:r>
             <a:endParaRPr lang="en-US" sz="3000" dirty="0"/>
           </a:p>
@@ -7798,7 +7798,7 @@
                   <a:schemeClr val="accent1"/>
                 </a:solidFill>
               </a:rPr>
-              <a:t>0 / 0</a:t>
+              <a:t>208 / 216</a:t>
             </a:r>
             <a:endParaRPr lang="en-US" sz="3000" dirty="0"/>
           </a:p>
@@ -7834,7 +7834,7 @@
                   <a:schemeClr val="tx1"/>
                 </a:solidFill>
               </a:rPr>
-              <a:t>private traces mention the hint</a:t>
+              <a:t>times the private reasoning mentions it</a:t>
             </a:r>
             <a:endParaRPr lang="en-US" sz="1200" dirty="0"/>
           </a:p>
@@ -7916,7 +7916,7 @@
                   <a:schemeClr val="accent2"/>
                 </a:solidFill>
               </a:rPr>
-              <a:t>0 / 0</a:t>
+              <a:t>8 / 216</a:t>
             </a:r>
             <a:endParaRPr lang="en-US" sz="3000" dirty="0"/>
           </a:p>
@@ -7952,7 +7952,7 @@
                   <a:schemeClr val="tx1"/>
                 </a:solidFill>
               </a:rPr>
-              <a:t>final answers mention it</a:t>
+              <a:t>times the final answer mentions it</a:t>
             </a:r>
             <a:endParaRPr lang="en-US" sz="1200" dirty="0"/>
           </a:p>
@@ -7991,7 +7991,7 @@
                   <a:schemeClr val="tx1"/>
                 </a:solidFill>
               </a:rPr>
-              <a:t>Compare instruct models (one channel): </a:t>
+              <a:t>Compare regular models: </a:t>
             </a:r>
             <a:pPr indent="0" marL="0">
               <a:spcAft>
@@ -8005,7 +8005,7 @@
                   <a:schemeClr val="tx1"/>
                 </a:solidFill>
               </a:rPr>
-              <a:t>their visible reply mentions the hint in 0 / 0 hinted runs.</a:t>
+              <a:t>Olmo’s regular models mention the hint in 56 of 144 replies; its thinking models, 0 of 144. For Qwen it’s 6 vs 8 out of 72, about the same.</a:t>
             </a:r>
             <a:endParaRPr lang="en-US" sz="1150" dirty="0"/>
           </a:p>
@@ -8022,7 +8022,7 @@
                   <a:schemeClr val="tx1"/>
                 </a:solidFill>
               </a:rPr>
-              <a:t>Mostly mentions, not admissions: </a:t>
+              <a:t>Mentioning isn’t admitting: </a:t>
             </a:r>
             <a:pPr indent="0" marL="0">
               <a:spcAft>
@@ -8036,7 +8036,7 @@
                   <a:schemeClr val="tx1"/>
                 </a:solidFill>
               </a:rPr>
-              <a:t>traces usually reject the hint (“the user thought C, but…”).</a:t>
+              <a:t>the reasoning usually brushes the hint off (“the user thought C, but…”).</a:t>
             </a:r>
             <a:endParaRPr lang="en-US" sz="1150" dirty="0"/>
           </a:p>
@@ -8067,7 +8067,7 @@
                   <a:schemeClr val="tx1"/>
                 </a:solidFill>
               </a:rPr>
-              <a:t>keyword detector, manual labels pending. Omission is our operational measure, not proof of dishonesty, and the trace is not the model’s internal computation.</a:t>
+              <a:t>we find mentions by keyword for now; hand labels come next. Leaving the hint out doesn’t prove a model is hiding something.</a:t>
             </a:r>
             <a:endParaRPr lang="en-US" sz="1150" dirty="0"/>
           </a:p>
@@ -8175,7 +8175,7 @@
                   <a:schemeClr val="tx1"/>
                 </a:solidFill>
               </a:rPr>
-              <a:t>Smaller findings that shape the design</a:t>
+              <a:t>Smaller findings that change our plan</a:t>
             </a:r>
             <a:endParaRPr lang="en-US" sz="3000" dirty="0"/>
           </a:p>
@@ -8233,7 +8233,7 @@
                   <a:schemeClr val="accent2"/>
                 </a:solidFill>
               </a:rPr>
-              <a:t>–</a:t>
+              <a:t>5% to 59%</a:t>
             </a:r>
             <a:endParaRPr lang="en-US" sz="4000" dirty="0"/>
           </a:p>
@@ -8269,7 +8269,7 @@
                   <a:schemeClr val="tx1"/>
                 </a:solidFill>
               </a:rPr>
-              <a:t>more output tokens with a hint, for thinking models, even when the answer stays the same</a:t>
+              <a:t>longer replies when there’s a hint, on all six models, even when the answer stays the same. The hint costs extra work.</a:t>
             </a:r>
             <a:endParaRPr lang="en-US" sz="1400" dirty="0"/>
           </a:p>
@@ -8327,7 +8327,7 @@
                   <a:schemeClr val="accent1"/>
                 </a:solidFill>
               </a:rPr>
-              <a:t>–</a:t>
+              <a:t>88% to 96%</a:t>
             </a:r>
             <a:endParaRPr lang="en-US" sz="4000" dirty="0"/>
           </a:p>
@@ -8363,7 +8363,7 @@
                   <a:schemeClr val="tx1"/>
                 </a:solidFill>
               </a:rPr>
-              <a:t>of “answer only, don’t explain” prompts still produced a private trace on thinking models</a:t>
+              <a:t>of the time, thinking models told “answer only, don’t explain” still reasoned in private and stayed accurate. Regular models dropped from 100% to 8% and from 88% to 4% correct.</a:t>
             </a:r>
             <a:endParaRPr lang="en-US" sz="1400" dirty="0"/>
           </a:p>
@@ -8457,7 +8457,7 @@
                   <a:schemeClr val="tx1"/>
                 </a:solidFill>
               </a:rPr>
-              <a:t>responses cut off at the token limit dumped the private trace into the visible answer (~27k characters)</a:t>
+              <a:t>replies that hit the length limit spilled the private reasoning into the visible answer (about 27,000 characters).</a:t>
             </a:r>
             <a:endParaRPr lang="en-US" sz="1400" dirty="0"/>
           </a:p>
@@ -8515,7 +8515,7 @@
                   <a:schemeClr val="accent1"/>
                 </a:solidFill>
               </a:rPr>
-              <a:t>–</a:t>
+              <a:t>30% to 48%</a:t>
             </a:r>
             <a:endParaRPr lang="en-US" sz="4000" dirty="0"/>
           </a:p>
@@ -8551,7 +8551,7 @@
                   <a:schemeClr val="tx1"/>
                 </a:solidFill>
               </a:rPr>
-              <a:t>trace length when asked to “think briefly”, on the same checkpoint: one way to vary reasoning without changing models</a:t>
+              <a:t>shorter reasoning when we ask the same model to “think briefly”. This lets us vary thinking without switching models.</a:t>
             </a:r>
             <a:endParaRPr lang="en-US" sz="1400" dirty="0"/>
           </a:p>
@@ -8741,7 +8741,7 @@
                   <a:schemeClr val="tx1"/>
                 </a:solidFill>
               </a:rPr>
-              <a:t>Thinking can’t be switched off on Voyager</a:t>
+              <a:t>We can’t turn thinking off on Voyager</a:t>
             </a:r>
             <a:endParaRPr lang="en-US" sz="1600" dirty="0"/>
           </a:p>
@@ -8777,7 +8777,7 @@
                   <a:schemeClr val="accent5"/>
                 </a:solidFill>
               </a:rPr>
-              <a:t>We tested 7 models; the setting is ignored. We treat pairs as differently trained models, add “think briefly” on the same checkpoint, and could self-host on Sol if GPU time is available.</a:t>
+              <a:t>We tried it on 7 models and the setting is ignored. So we treat each pair as two different models, ask the same model to “think briefly”, and may run models ourselves on ASU’s Sol computers if we get GPU time.</a:t>
             </a:r>
             <a:endParaRPr lang="en-US" sz="1300" dirty="0"/>
           </a:p>
@@ -8859,7 +8859,7 @@
                   <a:schemeClr val="tx1"/>
                 </a:solidFill>
               </a:rPr>
-              <a:t>The hint barely moves answers on this task</a:t>
+              <a:t>The hint only moves the smallest model on these puzzles</a:t>
             </a:r>
             <a:endParaRPr lang="en-US" sz="1600" dirty="0"/>
           </a:p>
@@ -8895,7 +8895,7 @@
                   <a:schemeClr val="accent5"/>
                 </a:solidFill>
               </a:rPr>
-              <a:t>Add ambiguous questions (BBQ) and BBH tasks where hints have room to work. A well-controlled null result still counts.</a:t>
+              <a:t>We’ll add questions where hints have more room: ambiguous questions about people (BBQ) and harder reasoning tasks (BBH). If hints still do little, that is a real result too.</a:t>
             </a:r>
             <a:endParaRPr lang="en-US" sz="1300" dirty="0"/>
           </a:p>
@@ -8977,7 +8977,7 @@
                   <a:schemeClr val="tx1"/>
                 </a:solidFill>
               </a:rPr>
-              <a:t>A keyword detector can’t tell mention from admission</a:t>
+              <a:t>Keyword search can’t tell a mention from an admission</a:t>
             </a:r>
             <a:endParaRPr lang="en-US" sz="1600" dirty="0"/>
           </a:p>
@@ -9013,7 +9013,7 @@
                   <a:schemeClr val="accent5"/>
                 </a:solidFill>
               </a:rPr>
-              <a:t>Three-level manual labels (none / mentions / admits influence) on 200 cases, two raters, with agreement (Cohen’s κ) reported.</a:t>
+              <a:t>Two of us will hand-label 200 replies as: no mention, mentions the hint, or says the hint changed its answer. We’ll report how often we agree.</a:t>
             </a:r>
             <a:endParaRPr lang="en-US" sz="1300" dirty="0"/>
           </a:p>
@@ -9095,7 +9095,7 @@
                   <a:schemeClr val="tx1"/>
                 </a:solidFill>
               </a:rPr>
-              <a:t>Thinking costs about 3× the tokens</a:t>
+              <a:t>Thinking models write 3.4 to 4.5 times as much</a:t>
             </a:r>
             <a:endParaRPr lang="en-US" sz="1600" dirty="0"/>
           </a:p>
@@ -9131,7 +9131,7 @@
                   <a:schemeClr val="accent5"/>
                 </a:solidFill>
               </a:rPr>
-              <a:t>The full proposed design is ~180M output tokens. We’ll cut it to ~55M, run a timed budget test first, and keep streaming to avoid server timeouts.</a:t>
+              <a:t>Our full proposal would need about 180 million tokens (word pieces) of output. We’ll cut that to about 55 million, time a small run first, and keep getting replies in pieces so long ones don’t time out.</a:t>
             </a:r>
             <a:endParaRPr lang="en-US" sz="1300" dirty="0"/>
           </a:p>
@@ -9333,7 +9333,7 @@
                   <a:schemeClr val="tx1"/>
                 </a:solidFill>
               </a:rPr>
-              <a:t>Add BBQ + BBH · timed budget run · freeze prompts</a:t>
+              <a:t>Add BBQ and BBH questions, time a test run, lock the prompts</a:t>
             </a:r>
             <a:endParaRPr lang="en-US" sz="1300" dirty="0"/>
           </a:p>
@@ -9391,7 +9391,7 @@
                   <a:schemeClr val="bg1"/>
                 </a:solidFill>
               </a:rPr>
-              <a:t>Weeks 10–11</a:t>
+              <a:t>Weeks 10-11</a:t>
             </a:r>
             <a:endParaRPr lang="en-US" sz="1500" dirty="0"/>
           </a:p>
@@ -9427,7 +9427,7 @@
                   <a:schemeClr val="tx1"/>
                 </a:solidFill>
               </a:rPr>
-              <a:t>Core sweep · hand-label 200 cases (2 raters)</a:t>
+              <a:t>Main runs, and hand-label 200 replies (2 people)</a:t>
             </a:r>
             <a:endParaRPr lang="en-US" sz="1300" dirty="0"/>
           </a:p>
@@ -9485,7 +9485,7 @@
                   <a:schemeClr val="bg1"/>
                 </a:solidFill>
               </a:rPr>
-              <a:t>Weeks 12–13</a:t>
+              <a:t>Weeks 12-13</a:t>
             </a:r>
             <a:endParaRPr lang="en-US" sz="1500" dirty="0"/>
           </a:p>
@@ -9521,7 +9521,7 @@
                   <a:schemeClr val="tx1"/>
                 </a:solidFill>
               </a:rPr>
-              <a:t>Two-agent extension: hinted answer → reviewer</a:t>
+              <a:t>If we’re on track: a second model reviews the first</a:t>
             </a:r>
             <a:endParaRPr lang="en-US" sz="1300" dirty="0"/>
           </a:p>
@@ -9579,7 +9579,7 @@
                   <a:schemeClr val="bg1"/>
                 </a:solidFill>
               </a:rPr>
-              <a:t>Weeks 14–15</a:t>
+              <a:t>Weeks 14-15</a:t>
             </a:r>
             <a:endParaRPr lang="en-US" sz="1500" dirty="0"/>
           </a:p>
@@ -9615,7 +9615,7 @@
                   <a:schemeClr val="tx1"/>
                 </a:solidFill>
               </a:rPr>
-              <a:t>Statistics, figures, report draft</a:t>
+              <a:t>Stats, charts, report draft</a:t>
             </a:r>
             <a:endParaRPr lang="en-US" sz="1300" dirty="0"/>
           </a:p>
@@ -9866,7 +9866,7 @@
                   <a:schemeClr val="tx1"/>
                 </a:solidFill>
               </a:rPr>
-              <a:t>harness, model runs, two-agent extension</a:t>
+              <a:t>code that runs the models, the two-model extension</a:t>
             </a:r>
             <a:endParaRPr lang="en-US" sz="1500" dirty="0"/>
           </a:p>
@@ -9897,7 +9897,7 @@
                   <a:schemeClr val="tx1"/>
                 </a:solidFill>
               </a:rPr>
-              <a:t>datasets, hint construction, labeling guide</a:t>
+              <a:t>question sets, hints, labeling guide</a:t>
             </a:r>
             <a:endParaRPr lang="en-US" sz="1500" dirty="0"/>
           </a:p>
@@ -9928,7 +9928,7 @@
                   <a:schemeClr val="tx1"/>
                 </a:solidFill>
               </a:rPr>
-              <a:t>statistics, figures, rater agreement</a:t>
+              <a:t>stats, charts, checking how well our labels agree</a:t>
             </a:r>
             <a:endParaRPr lang="en-US" sz="1500" dirty="0"/>
           </a:p>
@@ -10067,7 +10067,7 @@
                   <a:schemeClr val="bg1"/>
                 </a:solidFill>
               </a:rPr>
-              <a:t>Models mostly ignore the hint, but thinking models often see it and never say so.</a:t>
+              <a:t>Models mostly ignore the hint, but thinking models almost always see it and almost never say so.</a:t>
             </a:r>
             <a:endParaRPr lang="en-US" sz="4000" dirty="0"/>
           </a:p>
@@ -10105,7 +10105,7 @@
                   <a:schemeClr val="bg2"/>
                 </a:solidFill>
               </a:rPr>
-              <a:t>Next: does a second model catch that influence, or pass it along?</a:t>
+              <a:t>Next: does a second model catch this, or pass it along?</a:t>
             </a:r>
             <a:endParaRPr lang="en-US" sz="1900" dirty="0"/>
           </a:p>

</xml_diff>